<commit_message>
critto.org domain + QR on deck and README
</commit_message>
<xml_diff>
--- a/slides/Critto-Pitch.pptx
+++ b/slides/Critto-Pitch.pptx
@@ -2291,7 +2291,7 @@
                 <a:ea typeface="Calibri" pitchFamily="34" charset="-122"/>
                 <a:cs typeface="Calibri" pitchFamily="34" charset="-120"/>
               </a:rPr>
-              <a:t>SA image ID + collection, live on AMD</a:t>
+              <a:t>SA image ID + collection — live now</a:t>
             </a:r>
             <a:endParaRPr lang="en-US" sz="1400" dirty="0"/>
           </a:p>
@@ -2867,7 +2867,7 @@
         <p:spPr>
           <a:xfrm>
             <a:off x="640080" y="2011680"/>
-            <a:ext cx="8229600" cy="548640"/>
+            <a:ext cx="7498080" cy="548640"/>
           </a:xfrm>
           <a:prstGeom prst="rect">
             <a:avLst/>
@@ -2891,7 +2891,7 @@
                 <a:ea typeface="Calibri" pitchFamily="34" charset="-122"/>
                 <a:cs typeface="Calibri" pitchFamily="34" charset="-120"/>
               </a:rPr>
-              <a:t>It's live and running on AMD right now.</a:t>
+              <a:t>It's live — try it right now.</a:t>
             </a:r>
             <a:endParaRPr lang="en-US" sz="1800" dirty="0"/>
           </a:p>
@@ -2905,7 +2905,7 @@
         </p:nvSpPr>
         <p:spPr>
           <a:xfrm>
-            <a:off x="640080" y="3108960"/>
+            <a:off x="640080" y="3291840"/>
             <a:ext cx="4572000" cy="457200"/>
           </a:xfrm>
           <a:prstGeom prst="rect">
@@ -2944,24 +2944,24 @@
         </p:nvSpPr>
         <p:spPr>
           <a:xfrm>
-            <a:off x="640080" y="3566160"/>
-            <a:ext cx="6400800" cy="640080"/>
-          </a:xfrm>
-          <a:prstGeom prst="rect">
-            <a:avLst/>
-          </a:prstGeom>
-          <a:noFill/>
-          <a:ln/>
-        </p:spPr>
-        <p:txBody>
-          <a:bodyPr wrap="square" rtlCol="0" anchor="ctr"/>
-          <a:lstStyle/>
-          <a:p>
-            <a:pPr indent="0" marL="0">
-              <a:buNone/>
-            </a:pPr>
-            <a:r>
-              <a:rPr lang="en-US" sz="2800" b="1" dirty="0">
+            <a:off x="640080" y="3749040"/>
+            <a:ext cx="6400800" cy="822960"/>
+          </a:xfrm>
+          <a:prstGeom prst="rect">
+            <a:avLst/>
+          </a:prstGeom>
+          <a:noFill/>
+          <a:ln/>
+        </p:spPr>
+        <p:txBody>
+          <a:bodyPr wrap="square" rtlCol="0" anchor="ctr"/>
+          <a:lstStyle/>
+          <a:p>
+            <a:pPr indent="0" marL="0">
+              <a:buNone/>
+            </a:pPr>
+            <a:r>
+              <a:rPr lang="en-US" sz="4400" b="1" dirty="0">
                 <a:solidFill>
                   <a:srgbClr val="F6C451"/>
                 </a:solidFill>
@@ -2969,9 +2969,9 @@
                 <a:ea typeface="Cambria" pitchFamily="34" charset="-122"/>
                 <a:cs typeface="Cambria" pitchFamily="34" charset="-120"/>
               </a:rPr>
-              <a:t>&lt; your live URL &gt;</a:t>
-            </a:r>
-            <a:endParaRPr lang="en-US" sz="2800" dirty="0"/>
+              <a:t>critto.org</a:t>
+            </a:r>
+            <a:endParaRPr lang="en-US" sz="4400" dirty="0"/>
           </a:p>
         </p:txBody>
       </p:sp>
@@ -2983,12 +2983,12 @@
         </p:nvSpPr>
         <p:spPr>
           <a:xfrm>
-            <a:off x="8778240" y="2377440"/>
-            <a:ext cx="2651760" cy="2651760"/>
+            <a:off x="8595360" y="2697480"/>
+            <a:ext cx="2743200" cy="2743200"/>
           </a:xfrm>
           <a:prstGeom prst="roundRect">
             <a:avLst>
-              <a:gd name="adj" fmla="val 3448"/>
+              <a:gd name="adj" fmla="val 4000"/>
             </a:avLst>
           </a:prstGeom>
           <a:solidFill>
@@ -2997,16 +2997,40 @@
           <a:ln/>
         </p:spPr>
       </p:sp>
-      <p:sp>
-        <p:nvSpPr>
-          <p:cNvPr id="10" name="Text 8"/>
-          <p:cNvSpPr/>
-          <p:nvPr/>
-        </p:nvSpPr>
-        <p:spPr>
-          <a:xfrm>
-            <a:off x="8778240" y="2377440"/>
-            <a:ext cx="2651760" cy="2651760"/>
+      <p:pic>
+        <p:nvPicPr>
+          <p:cNvPr id="10" name="Image 0" descr="critto-qr.png">    </p:cNvPr>
+          <p:cNvPicPr>
+            <a:picLocks noChangeAspect="1"/>
+          </p:cNvPicPr>
+          <p:nvPr/>
+        </p:nvPicPr>
+        <p:blipFill>
+          <a:blip r:embed="rId1"/>
+          <a:stretch>
+            <a:fillRect/>
+          </a:stretch>
+        </p:blipFill>
+        <p:spPr>
+          <a:xfrm>
+            <a:off x="8778240" y="2880360"/>
+            <a:ext cx="2377440" cy="2377440"/>
+          </a:xfrm>
+          <a:prstGeom prst="rect">
+            <a:avLst/>
+          </a:prstGeom>
+        </p:spPr>
+      </p:pic>
+      <p:sp>
+        <p:nvSpPr>
+          <p:cNvPr id="11" name="Text 8"/>
+          <p:cNvSpPr/>
+          <p:nvPr/>
+        </p:nvSpPr>
+        <p:spPr>
+          <a:xfrm>
+            <a:off x="8503920" y="5532120"/>
+            <a:ext cx="2926080" cy="365760"/>
           </a:xfrm>
           <a:prstGeom prst="rect">
             <a:avLst/>
@@ -3022,17 +3046,17 @@
               <a:buNone/>
             </a:pPr>
             <a:r>
-              <a:rPr lang="en-US" sz="1600" dirty="0">
-                <a:solidFill>
-                  <a:srgbClr val="5B6B63"/>
+              <a:rPr lang="en-US" sz="1300" dirty="0">
+                <a:solidFill>
+                  <a:srgbClr val="9FD6C6"/>
                 </a:solidFill>
                 <a:latin typeface="Calibri" pitchFamily="34" charset="0"/>
                 <a:ea typeface="Calibri" pitchFamily="34" charset="-122"/>
                 <a:cs typeface="Calibri" pitchFamily="34" charset="-120"/>
               </a:rPr>
-              <a:t>[ QR code ]</a:t>
-            </a:r>
-            <a:endParaRPr lang="en-US" sz="1600" dirty="0"/>
+              <a:t>Scan to open critto.org</a:t>
+            </a:r>
+            <a:endParaRPr lang="en-US" sz="1300" dirty="0"/>
           </a:p>
         </p:txBody>
       </p:sp>
@@ -5691,7 +5715,7 @@
               <a:buNone/>
             </a:pPr>
             <a:r>
-              <a:rPr lang="en-US" sz="4800" b="1" dirty="0">
+              <a:rPr lang="en-US" sz="4400" b="1" dirty="0">
                 <a:solidFill>
                   <a:srgbClr val="175049"/>
                 </a:solidFill>
@@ -5701,7 +5725,7 @@
               </a:rPr>
               <a:t>99.95%</a:t>
             </a:r>
-            <a:endParaRPr lang="en-US" sz="4800" dirty="0"/>
+            <a:endParaRPr lang="en-US" sz="4400" dirty="0"/>
           </a:p>
         </p:txBody>
       </p:sp>
@@ -5808,7 +5832,7 @@
               <a:buNone/>
             </a:pPr>
             <a:r>
-              <a:rPr lang="en-US" sz="4800" b="1" dirty="0">
+              <a:rPr lang="en-US" sz="4400" b="1" dirty="0">
                 <a:solidFill>
                   <a:srgbClr val="175049"/>
                 </a:solidFill>
@@ -5818,7 +5842,7 @@
               </a:rPr>
               <a:t>150</a:t>
             </a:r>
-            <a:endParaRPr lang="en-US" sz="4800" dirty="0"/>
+            <a:endParaRPr lang="en-US" sz="4400" dirty="0"/>
           </a:p>
         </p:txBody>
       </p:sp>
@@ -5925,7 +5949,7 @@
               <a:buNone/>
             </a:pPr>
             <a:r>
-              <a:rPr lang="en-US" sz="4800" b="1" dirty="0">
+              <a:rPr lang="en-US" sz="4400" b="1" dirty="0">
                 <a:solidFill>
                   <a:srgbClr val="175049"/>
                 </a:solidFill>
@@ -5935,7 +5959,7 @@
               </a:rPr>
               <a:t>3</a:t>
             </a:r>
-            <a:endParaRPr lang="en-US" sz="4800" dirty="0"/>
+            <a:endParaRPr lang="en-US" sz="4400" dirty="0"/>
           </a:p>
         </p:txBody>
       </p:sp>
@@ -6042,7 +6066,7 @@
               <a:buNone/>
             </a:pPr>
             <a:r>
-              <a:rPr lang="en-US" sz="4800" b="1" dirty="0">
+              <a:rPr lang="en-US" sz="4400" b="1" dirty="0">
                 <a:solidFill>
                   <a:srgbClr val="175049"/>
                 </a:solidFill>
@@ -6052,7 +6076,7 @@
               </a:rPr>
               <a:t>2</a:t>
             </a:r>
-            <a:endParaRPr lang="en-US" sz="4800" dirty="0"/>
+            <a:endParaRPr lang="en-US" sz="4400" dirty="0"/>
           </a:p>
         </p:txBody>
       </p:sp>
@@ -6572,7 +6596,7 @@
                 <a:ea typeface="Calibri" pitchFamily="34" charset="-122"/>
                 <a:cs typeface="Calibri" pitchFamily="34" charset="-120"/>
               </a:rPr>
-              <a:t>Generic badges</a:t>
+              <a:t>Generic, forgettable rewards</a:t>
             </a:r>
             <a:endParaRPr lang="en-US" sz="1400" dirty="0"/>
           </a:p>

</xml_diff>

<commit_message>
Reposition messaging around depth and learning
</commit_message>
<xml_diff>
--- a/slides/Critto-Pitch.pptx
+++ b/slides/Critto-Pitch.pptx
@@ -2565,7 +2565,7 @@
                 <a:ea typeface="Calibri" pitchFamily="34" charset="-122"/>
                 <a:cs typeface="Calibri" pitchFamily="34" charset="-120"/>
               </a:rPr>
-              <a:t>Beyond SA — region-by-region expansion</a:t>
+              <a:t>Beyond SA — more species and regions</a:t>
             </a:r>
             <a:endParaRPr lang="en-US" sz="1400" dirty="0"/>
           </a:p>
@@ -3509,7 +3509,7 @@
                 <a:ea typeface="Cambria" pitchFamily="34" charset="-122"/>
                 <a:cs typeface="Cambria" pitchFamily="34" charset="-120"/>
               </a:rPr>
-              <a:t>People are disconnected from the wild</a:t>
+              <a:t>Knowing a name isn't knowing the animal</a:t>
             </a:r>
             <a:endParaRPr lang="en-US" sz="3400" dirty="0"/>
           </a:p>
@@ -3607,7 +3607,7 @@
                 <a:ea typeface="Cambria" pitchFamily="34" charset="-122"/>
                 <a:cs typeface="Cambria" pitchFamily="34" charset="-120"/>
               </a:rPr>
-              <a:t>Generic tools</a:t>
+              <a:t>Hard to identify</a:t>
             </a:r>
             <a:endParaRPr lang="en-US" sz="2000" dirty="0"/>
           </a:p>
@@ -3646,7 +3646,7 @@
                 <a:ea typeface="Calibri" pitchFamily="34" charset="-122"/>
                 <a:cs typeface="Calibri" pitchFamily="34" charset="-120"/>
               </a:rPr>
-              <a:t>Global apps recognise 80,000 species but know nothing local — no South African depth, no conservation context.</a:t>
+              <a:t>Faced with an unfamiliar bird, mammal, or snake, most people have no idea what they're looking at.</a:t>
             </a:r>
             <a:endParaRPr lang="en-US" sz="1500" dirty="0"/>
           </a:p>
@@ -3744,7 +3744,7 @@
                 <a:ea typeface="Cambria" pitchFamily="34" charset="-122"/>
                 <a:cs typeface="Cambria" pitchFamily="34" charset="-120"/>
               </a:rPr>
-              <a:t>Progress vanishes</a:t>
+              <a:t>A name isn't enough</a:t>
             </a:r>
             <a:endParaRPr lang="en-US" sz="2000" dirty="0"/>
           </a:p>
@@ -3783,7 +3783,7 @@
                 <a:ea typeface="Calibri" pitchFamily="34" charset="-122"/>
                 <a:cs typeface="Calibri" pitchFamily="34" charset="-120"/>
               </a:rPr>
-              <a:t>No accounts: switch phones and your sightings and journal are gone.</a:t>
+              <a:t>Even when you get a name, you don't learn anything about it — or remember it tomorrow.</a:t>
             </a:r>
             <a:endParaRPr lang="en-US" sz="1500" dirty="0"/>
           </a:p>
@@ -3881,7 +3881,7 @@
                 <a:ea typeface="Cambria" pitchFamily="34" charset="-122"/>
                 <a:cs typeface="Cambria" pitchFamily="34" charset="-120"/>
               </a:rPr>
-              <a:t>Shallow engagement</a:t>
+              <a:t>Nothing pulls you back</a:t>
             </a:r>
             <a:endParaRPr lang="en-US" sz="2000" dirty="0"/>
           </a:p>
@@ -3920,7 +3920,7 @@
                 <a:ea typeface="Calibri" pitchFamily="34" charset="-122"/>
                 <a:cs typeface="Calibri" pitchFamily="34" charset="-120"/>
               </a:rPr>
-              <a:t>Rewards you forget. They don't teach you anything or get you outside.</a:t>
+              <a:t>No reason to keep exploring, collecting, or caring about the wildlife around you.</a:t>
             </a:r>
             <a:endParaRPr lang="en-US" sz="1500" dirty="0"/>
           </a:p>
@@ -3959,7 +3959,7 @@
                 <a:ea typeface="Calibri" pitchFamily="34" charset="-122"/>
                 <a:cs typeface="Calibri" pitchFamily="34" charset="-120"/>
               </a:rPr>
-              <a:t>South Africa: 850+ bird species, the Big Five, a multi-billion-dollar wildlife-tourism draw — served only by generic apps.</a:t>
+              <a:t>People want to understand the wildlife around them — not just tag it and move on.</a:t>
             </a:r>
             <a:endParaRPr lang="en-US" sz="1300" dirty="0"/>
           </a:p>
@@ -6240,7 +6240,7 @@
                 <a:ea typeface="Calibri" pitchFamily="34" charset="-122"/>
                 <a:cs typeface="Calibri" pitchFamily="34" charset="-120"/>
               </a:rPr>
-              <a:t>DIFFERENTIATION</a:t>
+              <a:t>OUR DIFFERENCE</a:t>
             </a:r>
             <a:endParaRPr lang="en-US" sz="1300" dirty="0"/>
           </a:p>
@@ -6279,7 +6279,7 @@
                 <a:ea typeface="Cambria" pitchFamily="34" charset="-122"/>
                 <a:cs typeface="Cambria" pitchFamily="34" charset="-120"/>
               </a:rPr>
-              <a:t>Why Critto, not a generic ID app</a:t>
+              <a:t>We go deeper</a:t>
             </a:r>
             <a:endParaRPr lang="en-US" sz="3400" dirty="0"/>
           </a:p>
@@ -6287,86 +6287,101 @@
       </p:sp>
       <p:sp>
         <p:nvSpPr>
-          <p:cNvPr id="4" name="Shape 2"/>
-          <p:cNvSpPr/>
-          <p:nvPr/>
-        </p:nvSpPr>
-        <p:spPr>
-          <a:xfrm>
-            <a:off x="640080" y="2011680"/>
-            <a:ext cx="5394960" cy="4206240"/>
-          </a:xfrm>
-          <a:prstGeom prst="roundRect">
-            <a:avLst>
-              <a:gd name="adj" fmla="val 2609"/>
-            </a:avLst>
-          </a:prstGeom>
-          <a:solidFill>
-            <a:srgbClr val="EEF4F0"/>
-          </a:solidFill>
-          <a:ln/>
-        </p:spPr>
-      </p:sp>
-      <p:sp>
-        <p:nvSpPr>
-          <p:cNvPr id="5" name="Shape 3"/>
-          <p:cNvSpPr/>
-          <p:nvPr/>
-        </p:nvSpPr>
-        <p:spPr>
-          <a:xfrm>
-            <a:off x="6172200" y="2011680"/>
-            <a:ext cx="5394960" cy="4206240"/>
-          </a:xfrm>
-          <a:prstGeom prst="roundRect">
-            <a:avLst>
-              <a:gd name="adj" fmla="val 2609"/>
-            </a:avLst>
-          </a:prstGeom>
-          <a:solidFill>
-            <a:srgbClr val="175049"/>
-          </a:solidFill>
-          <a:ln/>
-        </p:spPr>
-      </p:sp>
-      <p:sp>
-        <p:nvSpPr>
-          <p:cNvPr id="6" name="Text 4"/>
-          <p:cNvSpPr/>
-          <p:nvPr/>
-        </p:nvSpPr>
-        <p:spPr>
-          <a:xfrm>
-            <a:off x="822960" y="2148840"/>
-            <a:ext cx="5029200" cy="457200"/>
-          </a:xfrm>
-          <a:prstGeom prst="rect">
-            <a:avLst/>
-          </a:prstGeom>
-          <a:noFill/>
-          <a:ln/>
-        </p:spPr>
-        <p:txBody>
-          <a:bodyPr wrap="square" rtlCol="0" anchor="ctr"/>
-          <a:lstStyle/>
-          <a:p>
-            <a:pPr indent="0" marL="0">
-              <a:buNone/>
-            </a:pPr>
-            <a:r>
-              <a:rPr lang="en-US" sz="1800" b="1" dirty="0">
-                <a:solidFill>
-                  <a:srgbClr val="5B6B63"/>
+          <p:cNvPr id="4" name="Text 2"/>
+          <p:cNvSpPr/>
+          <p:nvPr/>
+        </p:nvSpPr>
+        <p:spPr>
+          <a:xfrm>
+            <a:off x="640080" y="2286000"/>
+            <a:ext cx="5212080" cy="640080"/>
+          </a:xfrm>
+          <a:prstGeom prst="rect">
+            <a:avLst/>
+          </a:prstGeom>
+          <a:noFill/>
+          <a:ln/>
+        </p:spPr>
+        <p:txBody>
+          <a:bodyPr wrap="square" rtlCol="0" anchor="ctr"/>
+          <a:lstStyle/>
+          <a:p>
+            <a:pPr indent="0" marL="0">
+              <a:buNone/>
+            </a:pPr>
+            <a:r>
+              <a:rPr lang="en-US" sz="2600" b="1" dirty="0">
+                <a:solidFill>
+                  <a:srgbClr val="16261E"/>
                 </a:solidFill>
                 <a:latin typeface="Cambria" pitchFamily="34" charset="0"/>
                 <a:ea typeface="Cambria" pitchFamily="34" charset="-122"/>
                 <a:cs typeface="Cambria" pitchFamily="34" charset="-120"/>
               </a:rPr>
-              <a:t>Generic apps (e.g. Seek)</a:t>
-            </a:r>
-            <a:endParaRPr lang="en-US" sz="1800" dirty="0"/>
-          </a:p>
-        </p:txBody>
+              <a:t>A name is just the start.</a:t>
+            </a:r>
+            <a:endParaRPr lang="en-US" sz="2600" dirty="0"/>
+          </a:p>
+        </p:txBody>
+      </p:sp>
+      <p:sp>
+        <p:nvSpPr>
+          <p:cNvPr id="5" name="Text 3"/>
+          <p:cNvSpPr/>
+          <p:nvPr/>
+        </p:nvSpPr>
+        <p:spPr>
+          <a:xfrm>
+            <a:off x="640080" y="3108960"/>
+            <a:ext cx="5120640" cy="1828800"/>
+          </a:xfrm>
+          <a:prstGeom prst="rect">
+            <a:avLst/>
+          </a:prstGeom>
+          <a:noFill/>
+          <a:ln/>
+        </p:spPr>
+        <p:txBody>
+          <a:bodyPr wrap="square" rtlCol="0" anchor="ctr"/>
+          <a:lstStyle/>
+          <a:p>
+            <a:pPr indent="0" marL="0">
+              <a:buNone/>
+            </a:pPr>
+            <a:r>
+              <a:rPr lang="en-US" sz="1700" dirty="0">
+                <a:solidFill>
+                  <a:srgbClr val="5B6B63"/>
+                </a:solidFill>
+                <a:latin typeface="Calibri" pitchFamily="34" charset="0"/>
+                <a:ea typeface="Calibri" pitchFamily="34" charset="-122"/>
+                <a:cs typeface="Calibri" pitchFamily="34" charset="-120"/>
+              </a:rPr>
+              <a:t>Critto helps you actually learn about the wildlife around you — and keeps you coming back to discover more.</a:t>
+            </a:r>
+            <a:endParaRPr lang="en-US" sz="1700" dirty="0"/>
+          </a:p>
+        </p:txBody>
+      </p:sp>
+      <p:sp>
+        <p:nvSpPr>
+          <p:cNvPr id="6" name="Shape 4"/>
+          <p:cNvSpPr/>
+          <p:nvPr/>
+        </p:nvSpPr>
+        <p:spPr>
+          <a:xfrm>
+            <a:off x="6400800" y="2240280"/>
+            <a:ext cx="411480" cy="411480"/>
+          </a:xfrm>
+          <a:prstGeom prst="ellipse">
+            <a:avLst/>
+          </a:prstGeom>
+          <a:solidFill>
+            <a:srgbClr val="E0A32E"/>
+          </a:solidFill>
+          <a:ln/>
+        </p:spPr>
       </p:sp>
       <p:sp>
         <p:nvSpPr>
@@ -6376,8 +6391,8 @@
         </p:nvSpPr>
         <p:spPr>
           <a:xfrm>
-            <a:off x="6355080" y="2148840"/>
-            <a:ext cx="5029200" cy="457200"/>
+            <a:off x="7040880" y="2167128"/>
+            <a:ext cx="4754880" cy="365760"/>
           </a:xfrm>
           <a:prstGeom prst="rect">
             <a:avLst/>
@@ -6395,13 +6410,13 @@
             <a:r>
               <a:rPr lang="en-US" sz="1800" b="1" dirty="0">
                 <a:solidFill>
-                  <a:srgbClr val="F6C451"/>
+                  <a:srgbClr val="175049"/>
                 </a:solidFill>
                 <a:latin typeface="Cambria" pitchFamily="34" charset="0"/>
                 <a:ea typeface="Cambria" pitchFamily="34" charset="-122"/>
                 <a:cs typeface="Cambria" pitchFamily="34" charset="-120"/>
               </a:rPr>
-              <a:t>Critto</a:t>
+              <a:t>Rich, cited field guides</a:t>
             </a:r>
             <a:endParaRPr lang="en-US" sz="1800" dirty="0"/>
           </a:p>
@@ -6415,8 +6430,8 @@
         </p:nvSpPr>
         <p:spPr>
           <a:xfrm>
-            <a:off x="822960" y="2788920"/>
-            <a:ext cx="5029200" cy="777240"/>
+            <a:off x="7040880" y="2587752"/>
+            <a:ext cx="4754880" cy="731520"/>
           </a:xfrm>
           <a:prstGeom prst="rect">
             <a:avLst/>
@@ -6440,7 +6455,7 @@
                 <a:ea typeface="Calibri" pitchFamily="34" charset="-122"/>
                 <a:cs typeface="Calibri" pitchFamily="34" charset="-120"/>
               </a:rPr>
-              <a:t>Global &amp; shallow, all species</a:t>
+              <a:t>Habitat, diet, range, size, conservation — from real sources.</a:t>
             </a:r>
             <a:endParaRPr lang="en-US" sz="1400" dirty="0"/>
           </a:p>
@@ -6448,38 +6463,97 @@
       </p:sp>
       <p:sp>
         <p:nvSpPr>
-          <p:cNvPr id="9" name="Text 7"/>
-          <p:cNvSpPr/>
-          <p:nvPr/>
-        </p:nvSpPr>
-        <p:spPr>
-          <a:xfrm>
-            <a:off x="6355080" y="2788920"/>
-            <a:ext cx="5029200" cy="777240"/>
-          </a:xfrm>
-          <a:prstGeom prst="rect">
-            <a:avLst/>
-          </a:prstGeom>
-          <a:noFill/>
-          <a:ln/>
-        </p:spPr>
-        <p:txBody>
-          <a:bodyPr wrap="square" rtlCol="0" anchor="ctr"/>
-          <a:lstStyle/>
-          <a:p>
-            <a:pPr indent="0" marL="0">
-              <a:buNone/>
-            </a:pPr>
-            <a:r>
-              <a:rPr lang="en-US" sz="1400" b="1" dirty="0">
-                <a:solidFill>
-                  <a:srgbClr val="FDF7EA"/>
+          <p:cNvPr id="9" name="Shape 7"/>
+          <p:cNvSpPr/>
+          <p:nvPr/>
+        </p:nvSpPr>
+        <p:spPr>
+          <a:xfrm>
+            <a:off x="6400800" y="3566160"/>
+            <a:ext cx="411480" cy="411480"/>
+          </a:xfrm>
+          <a:prstGeom prst="ellipse">
+            <a:avLst/>
+          </a:prstGeom>
+          <a:solidFill>
+            <a:srgbClr val="9FD6C6"/>
+          </a:solidFill>
+          <a:ln/>
+        </p:spPr>
+      </p:sp>
+      <p:sp>
+        <p:nvSpPr>
+          <p:cNvPr id="10" name="Text 8"/>
+          <p:cNvSpPr/>
+          <p:nvPr/>
+        </p:nvSpPr>
+        <p:spPr>
+          <a:xfrm>
+            <a:off x="7040880" y="3493008"/>
+            <a:ext cx="4754880" cy="365760"/>
+          </a:xfrm>
+          <a:prstGeom prst="rect">
+            <a:avLst/>
+          </a:prstGeom>
+          <a:noFill/>
+          <a:ln/>
+        </p:spPr>
+        <p:txBody>
+          <a:bodyPr wrap="square" rtlCol="0" anchor="ctr"/>
+          <a:lstStyle/>
+          <a:p>
+            <a:pPr indent="0" marL="0">
+              <a:buNone/>
+            </a:pPr>
+            <a:r>
+              <a:rPr lang="en-US" sz="1800" b="1" dirty="0">
+                <a:solidFill>
+                  <a:srgbClr val="175049"/>
+                </a:solidFill>
+                <a:latin typeface="Cambria" pitchFamily="34" charset="0"/>
+                <a:ea typeface="Cambria" pitchFamily="34" charset="-122"/>
+                <a:cs typeface="Cambria" pitchFamily="34" charset="-120"/>
+              </a:rPr>
+              <a:t>Learn as you collect</a:t>
+            </a:r>
+            <a:endParaRPr lang="en-US" sz="1800" dirty="0"/>
+          </a:p>
+        </p:txBody>
+      </p:sp>
+      <p:sp>
+        <p:nvSpPr>
+          <p:cNvPr id="11" name="Text 9"/>
+          <p:cNvSpPr/>
+          <p:nvPr/>
+        </p:nvSpPr>
+        <p:spPr>
+          <a:xfrm>
+            <a:off x="7040880" y="3913632"/>
+            <a:ext cx="4754880" cy="731520"/>
+          </a:xfrm>
+          <a:prstGeom prst="rect">
+            <a:avLst/>
+          </a:prstGeom>
+          <a:noFill/>
+          <a:ln/>
+        </p:spPr>
+        <p:txBody>
+          <a:bodyPr wrap="square" rtlCol="0" anchor="ctr"/>
+          <a:lstStyle/>
+          <a:p>
+            <a:pPr indent="0" marL="0">
+              <a:buNone/>
+            </a:pPr>
+            <a:r>
+              <a:rPr lang="en-US" sz="1400" dirty="0">
+                <a:solidFill>
+                  <a:srgbClr val="16261E"/>
                 </a:solidFill>
                 <a:latin typeface="Calibri" pitchFamily="34" charset="0"/>
                 <a:ea typeface="Calibri" pitchFamily="34" charset="-122"/>
                 <a:cs typeface="Calibri" pitchFamily="34" charset="-120"/>
               </a:rPr>
-              <a:t>South Africa-deep, curated &amp; conservation-aware</a:t>
+              <a:t>Rarity, sets, and your Journal make it stick.</a:t>
             </a:r>
             <a:endParaRPr lang="en-US" sz="1400" dirty="0"/>
           </a:p>
@@ -6487,14 +6561,73 @@
       </p:sp>
       <p:sp>
         <p:nvSpPr>
-          <p:cNvPr id="10" name="Text 8"/>
-          <p:cNvSpPr/>
-          <p:nvPr/>
-        </p:nvSpPr>
-        <p:spPr>
-          <a:xfrm>
-            <a:off x="822960" y="3630168"/>
-            <a:ext cx="5029200" cy="777240"/>
+          <p:cNvPr id="12" name="Shape 10"/>
+          <p:cNvSpPr/>
+          <p:nvPr/>
+        </p:nvSpPr>
+        <p:spPr>
+          <a:xfrm>
+            <a:off x="6400800" y="4892040"/>
+            <a:ext cx="411480" cy="411480"/>
+          </a:xfrm>
+          <a:prstGeom prst="ellipse">
+            <a:avLst/>
+          </a:prstGeom>
+          <a:solidFill>
+            <a:srgbClr val="E0A32E"/>
+          </a:solidFill>
+          <a:ln/>
+        </p:spPr>
+      </p:sp>
+      <p:sp>
+        <p:nvSpPr>
+          <p:cNvPr id="13" name="Text 11"/>
+          <p:cNvSpPr/>
+          <p:nvPr/>
+        </p:nvSpPr>
+        <p:spPr>
+          <a:xfrm>
+            <a:off x="7040880" y="4818888"/>
+            <a:ext cx="4754880" cy="365760"/>
+          </a:xfrm>
+          <a:prstGeom prst="rect">
+            <a:avLst/>
+          </a:prstGeom>
+          <a:noFill/>
+          <a:ln/>
+        </p:spPr>
+        <p:txBody>
+          <a:bodyPr wrap="square" rtlCol="0" anchor="ctr"/>
+          <a:lstStyle/>
+          <a:p>
+            <a:pPr indent="0" marL="0">
+              <a:buNone/>
+            </a:pPr>
+            <a:r>
+              <a:rPr lang="en-US" sz="1800" b="1" dirty="0">
+                <a:solidFill>
+                  <a:srgbClr val="175049"/>
+                </a:solidFill>
+                <a:latin typeface="Cambria" pitchFamily="34" charset="0"/>
+                <a:ea typeface="Cambria" pitchFamily="34" charset="-122"/>
+                <a:cs typeface="Cambria" pitchFamily="34" charset="-120"/>
+              </a:rPr>
+              <a:t>Conservation built in</a:t>
+            </a:r>
+            <a:endParaRPr lang="en-US" sz="1800" dirty="0"/>
+          </a:p>
+        </p:txBody>
+      </p:sp>
+      <p:sp>
+        <p:nvSpPr>
+          <p:cNvPr id="14" name="Text 12"/>
+          <p:cNvSpPr/>
+          <p:nvPr/>
+        </p:nvSpPr>
+        <p:spPr>
+          <a:xfrm>
+            <a:off x="7040880" y="5239512"/>
+            <a:ext cx="4754880" cy="731520"/>
           </a:xfrm>
           <a:prstGeom prst="rect">
             <a:avLst/>
@@ -6518,202 +6651,7 @@
                 <a:ea typeface="Calibri" pitchFamily="34" charset="-122"/>
                 <a:cs typeface="Calibri" pitchFamily="34" charset="-120"/>
               </a:rPr>
-              <a:t>No accounts — lose your data on a new phone</a:t>
-            </a:r>
-            <a:endParaRPr lang="en-US" sz="1400" dirty="0"/>
-          </a:p>
-        </p:txBody>
-      </p:sp>
-      <p:sp>
-        <p:nvSpPr>
-          <p:cNvPr id="11" name="Text 9"/>
-          <p:cNvSpPr/>
-          <p:nvPr/>
-        </p:nvSpPr>
-        <p:spPr>
-          <a:xfrm>
-            <a:off x="6355080" y="3630168"/>
-            <a:ext cx="5029200" cy="777240"/>
-          </a:xfrm>
-          <a:prstGeom prst="rect">
-            <a:avLst/>
-          </a:prstGeom>
-          <a:noFill/>
-          <a:ln/>
-        </p:spPr>
-        <p:txBody>
-          <a:bodyPr wrap="square" rtlCol="0" anchor="ctr"/>
-          <a:lstStyle/>
-          <a:p>
-            <a:pPr indent="0" marL="0">
-              <a:buNone/>
-            </a:pPr>
-            <a:r>
-              <a:rPr lang="en-US" sz="1400" b="1" dirty="0">
-                <a:solidFill>
-                  <a:srgbClr val="FDF7EA"/>
-                </a:solidFill>
-                <a:latin typeface="Calibri" pitchFamily="34" charset="0"/>
-                <a:ea typeface="Calibri" pitchFamily="34" charset="-122"/>
-                <a:cs typeface="Calibri" pitchFamily="34" charset="-120"/>
-              </a:rPr>
-              <a:t>Cloud-synced collection — never lose your journal</a:t>
-            </a:r>
-            <a:endParaRPr lang="en-US" sz="1400" dirty="0"/>
-          </a:p>
-        </p:txBody>
-      </p:sp>
-      <p:sp>
-        <p:nvSpPr>
-          <p:cNvPr id="12" name="Text 10"/>
-          <p:cNvSpPr/>
-          <p:nvPr/>
-        </p:nvSpPr>
-        <p:spPr>
-          <a:xfrm>
-            <a:off x="822960" y="4471416"/>
-            <a:ext cx="5029200" cy="777240"/>
-          </a:xfrm>
-          <a:prstGeom prst="rect">
-            <a:avLst/>
-          </a:prstGeom>
-          <a:noFill/>
-          <a:ln/>
-        </p:spPr>
-        <p:txBody>
-          <a:bodyPr wrap="square" rtlCol="0" anchor="ctr"/>
-          <a:lstStyle/>
-          <a:p>
-            <a:pPr indent="0" marL="0">
-              <a:buNone/>
-            </a:pPr>
-            <a:r>
-              <a:rPr lang="en-US" sz="1400" dirty="0">
-                <a:solidFill>
-                  <a:srgbClr val="16261E"/>
-                </a:solidFill>
-                <a:latin typeface="Calibri" pitchFamily="34" charset="0"/>
-                <a:ea typeface="Calibri" pitchFamily="34" charset="-122"/>
-                <a:cs typeface="Calibri" pitchFamily="34" charset="-120"/>
-              </a:rPr>
-              <a:t>Generic, forgettable rewards</a:t>
-            </a:r>
-            <a:endParaRPr lang="en-US" sz="1400" dirty="0"/>
-          </a:p>
-        </p:txBody>
-      </p:sp>
-      <p:sp>
-        <p:nvSpPr>
-          <p:cNvPr id="13" name="Text 11"/>
-          <p:cNvSpPr/>
-          <p:nvPr/>
-        </p:nvSpPr>
-        <p:spPr>
-          <a:xfrm>
-            <a:off x="6355080" y="4471416"/>
-            <a:ext cx="5029200" cy="777240"/>
-          </a:xfrm>
-          <a:prstGeom prst="rect">
-            <a:avLst/>
-          </a:prstGeom>
-          <a:noFill/>
-          <a:ln/>
-        </p:spPr>
-        <p:txBody>
-          <a:bodyPr wrap="square" rtlCol="0" anchor="ctr"/>
-          <a:lstStyle/>
-          <a:p>
-            <a:pPr indent="0" marL="0">
-              <a:buNone/>
-            </a:pPr>
-            <a:r>
-              <a:rPr lang="en-US" sz="1400" b="1" dirty="0">
-                <a:solidFill>
-                  <a:srgbClr val="FDF7EA"/>
-                </a:solidFill>
-                <a:latin typeface="Calibri" pitchFamily="34" charset="0"/>
-                <a:ea typeface="Calibri" pitchFamily="34" charset="-122"/>
-                <a:cs typeface="Calibri" pitchFamily="34" charset="-120"/>
-              </a:rPr>
-              <a:t>Conservation-weighted rarity + meaningful sets</a:t>
-            </a:r>
-            <a:endParaRPr lang="en-US" sz="1400" dirty="0"/>
-          </a:p>
-        </p:txBody>
-      </p:sp>
-      <p:sp>
-        <p:nvSpPr>
-          <p:cNvPr id="14" name="Text 12"/>
-          <p:cNvSpPr/>
-          <p:nvPr/>
-        </p:nvSpPr>
-        <p:spPr>
-          <a:xfrm>
-            <a:off x="822960" y="5312664"/>
-            <a:ext cx="5029200" cy="777240"/>
-          </a:xfrm>
-          <a:prstGeom prst="rect">
-            <a:avLst/>
-          </a:prstGeom>
-          <a:noFill/>
-          <a:ln/>
-        </p:spPr>
-        <p:txBody>
-          <a:bodyPr wrap="square" rtlCol="0" anchor="ctr"/>
-          <a:lstStyle/>
-          <a:p>
-            <a:pPr indent="0" marL="0">
-              <a:buNone/>
-            </a:pPr>
-            <a:r>
-              <a:rPr lang="en-US" sz="1400" dirty="0">
-                <a:solidFill>
-                  <a:srgbClr val="16261E"/>
-                </a:solidFill>
-                <a:latin typeface="Calibri" pitchFamily="34" charset="0"/>
-                <a:ea typeface="Calibri" pitchFamily="34" charset="-122"/>
-                <a:cs typeface="Calibri" pitchFamily="34" charset="-120"/>
-              </a:rPr>
-              <a:t>Just a name and a fact</a:t>
-            </a:r>
-            <a:endParaRPr lang="en-US" sz="1400" dirty="0"/>
-          </a:p>
-        </p:txBody>
-      </p:sp>
-      <p:sp>
-        <p:nvSpPr>
-          <p:cNvPr id="15" name="Text 13"/>
-          <p:cNvSpPr/>
-          <p:nvPr/>
-        </p:nvSpPr>
-        <p:spPr>
-          <a:xfrm>
-            <a:off x="6355080" y="5312664"/>
-            <a:ext cx="5029200" cy="777240"/>
-          </a:xfrm>
-          <a:prstGeom prst="rect">
-            <a:avLst/>
-          </a:prstGeom>
-          <a:noFill/>
-          <a:ln/>
-        </p:spPr>
-        <p:txBody>
-          <a:bodyPr wrap="square" rtlCol="0" anchor="ctr"/>
-          <a:lstStyle/>
-          <a:p>
-            <a:pPr indent="0" marL="0">
-              <a:buNone/>
-            </a:pPr>
-            <a:r>
-              <a:rPr lang="en-US" sz="1400" b="1" dirty="0">
-                <a:solidFill>
-                  <a:srgbClr val="FDF7EA"/>
-                </a:solidFill>
-                <a:latin typeface="Calibri" pitchFamily="34" charset="0"/>
-                <a:ea typeface="Calibri" pitchFamily="34" charset="-122"/>
-                <a:cs typeface="Calibri" pitchFamily="34" charset="-120"/>
-              </a:rPr>
-              <a:t>Rich, cited field guide + read-aloud</a:t>
+              <a:t>See what's threatened and why it matters.</a:t>
             </a:r>
             <a:endParaRPr lang="en-US" sz="1400" dirty="0"/>
           </a:p>

</xml_diff>

<commit_message>
Accurate AMD GPU wording (not Instinct) for our classifier
</commit_message>
<xml_diff>
--- a/slides/Critto-Pitch.pptx
+++ b/slides/Critto-Pitch.pptx
@@ -5474,7 +5474,7 @@
                 <a:ea typeface="Cambria" pitchFamily="34" charset="-122"/>
                 <a:cs typeface="Cambria" pitchFamily="34" charset="-120"/>
               </a:rPr>
-              <a:t>BioCLIP on AMD Instinct (ROCm)</a:t>
+              <a:t>BioCLIP on AMD GPU (ROCm)</a:t>
             </a:r>
             <a:endParaRPr lang="en-US" sz="2100" dirty="0"/>
           </a:p>
@@ -5513,7 +5513,7 @@
                 <a:ea typeface="Calibri" pitchFamily="34" charset="-122"/>
                 <a:cs typeface="Calibri" pitchFamily="34" charset="-120"/>
               </a:rPr>
-              <a:t>Our specialised classifier is validated directly on AMD Instinct GPUs via ROCm — 99.95% on a test image. The high-accuracy vision path.</a:t>
+              <a:t>Our specialised classifier is validated directly on an AMD GPU via ROCm — 99.95% on a test image. The high-accuracy vision path.</a:t>
             </a:r>
             <a:endParaRPr lang="en-US" sz="1500" dirty="0"/>
           </a:p>
@@ -5552,7 +5552,7 @@
                 <a:ea typeface="Calibri" pitchFamily="34" charset="-122"/>
                 <a:cs typeface="Calibri" pitchFamily="34" charset="-120"/>
               </a:rPr>
-              <a:t>AMD on two fronts: our classifier on AMD Instinct (ROCm), and inference via Fireworks AI — AMD's partner.</a:t>
+              <a:t>AMD on two fronts: our classifier on an AMD GPU (ROCm), and inference via Fireworks AI — AMD's partner.</a:t>
             </a:r>
             <a:endParaRPr lang="en-US" sz="1500" dirty="0"/>
           </a:p>
@@ -5779,7 +5779,7 @@
                 <a:ea typeface="Calibri" pitchFamily="34" charset="-122"/>
                 <a:cs typeface="Calibri" pitchFamily="34" charset="-120"/>
               </a:rPr>
-              <a:t>Instinct (test)</a:t>
+              <a:t>GPU (test)</a:t>
             </a:r>
             <a:endParaRPr lang="en-US" sz="1400" dirty="0"/>
           </a:p>
@@ -6130,7 +6130,7 @@
                 <a:ea typeface="Calibri" pitchFamily="34" charset="-122"/>
                 <a:cs typeface="Calibri" pitchFamily="34" charset="-120"/>
               </a:rPr>
-              <a:t>Instinct + Fireworks</a:t>
+              <a:t>AMD GPU + Fireworks</a:t>
             </a:r>
             <a:endParaRPr lang="en-US" sz="1400" dirty="0"/>
           </a:p>

</xml_diff>